<commit_message>
actualizo los documentos de las actividades 1.2 y 1.3
Subo la version mas reciente del reporte de practica de la actividad 1.2
y vuelvo a subir el banco de ejercicios de la actividad 1.3 con los
cambios nuevos.

Corrijo el nombre del cuadro sinoptico de la actividad 1.1, que tenia un
guion bajo de mas.
</commit_message>
<xml_diff>
--- a/LYA-II-Tema-1/Actividad_1.2 Reporte_Practica__7ISC_AmauryGordillo_LYA-II.pptx
+++ b/LYA-II-Tema-1/Actividad_1.2 Reporte_Practica__7ISC_AmauryGordillo_LYA-II.pptx
@@ -426,19 +426,7 @@
           <a:bodyPr/>
           <a:lstStyle/>
           <a:p>
-            <a:r>
-              <a:t>[Sources]</a:t>
-            </a:r>
-          </a:p>
-          <a:p>
-            <a:r>
-              <a:t>- Contenido y evidencias elaborados por el estudiante.</a:t>
-            </a:r>
-          </a:p>
-          <a:p>
-            <a:r>
-              <a:t>[/Sources]</a:t>
-            </a:r>
+            <a:endParaRPr dirty="0"/>
           </a:p>
         </p:txBody>
       </p:sp>
@@ -513,19 +501,7 @@
           <a:bodyPr/>
           <a:lstStyle/>
           <a:p>
-            <a:r>
-              <a:t>[Sources]</a:t>
-            </a:r>
-          </a:p>
-          <a:p>
-            <a:r>
-              <a:t>- Contenido y evidencias elaborados por el estudiante.</a:t>
-            </a:r>
-          </a:p>
-          <a:p>
-            <a:r>
-              <a:t>[/Sources]</a:t>
-            </a:r>
+            <a:endParaRPr dirty="0"/>
           </a:p>
         </p:txBody>
       </p:sp>
@@ -600,19 +576,7 @@
           <a:bodyPr/>
           <a:lstStyle/>
           <a:p>
-            <a:r>
-              <a:t>[Sources]</a:t>
-            </a:r>
-          </a:p>
-          <a:p>
-            <a:r>
-              <a:t>- Contenido y evidencias elaborados por el estudiante.</a:t>
-            </a:r>
-          </a:p>
-          <a:p>
-            <a:r>
-              <a:t>[/Sources]</a:t>
-            </a:r>
+            <a:endParaRPr dirty="0"/>
           </a:p>
         </p:txBody>
       </p:sp>
@@ -687,19 +651,7 @@
           <a:bodyPr/>
           <a:lstStyle/>
           <a:p>
-            <a:r>
-              <a:t>[Sources]</a:t>
-            </a:r>
-          </a:p>
-          <a:p>
-            <a:r>
-              <a:t>- Contenido y evidencias elaborados por el estudiante.</a:t>
-            </a:r>
-          </a:p>
-          <a:p>
-            <a:r>
-              <a:t>[/Sources]</a:t>
-            </a:r>
+            <a:endParaRPr dirty="0"/>
           </a:p>
         </p:txBody>
       </p:sp>
@@ -774,24 +726,7 @@
           <a:bodyPr/>
           <a:lstStyle/>
           <a:p>
-            <a:r>
-              <a:t>La tabla registra cantidad, precio, total, producto y disponible. El valor total quedó en 102.5 y el estado indica Análisis correcto.</a:t>
-            </a:r>
-          </a:p>
-          <a:p>
-            <a:r>
-              <a:t>[Sources]</a:t>
-            </a:r>
-          </a:p>
-          <a:p>
-            <a:r>
-              <a:t>- Evidencia de ejecución proporcionada por el estudiante: 9ca588f4-6bd8-4193-9ba5-0428c55db266.png</a:t>
-            </a:r>
-          </a:p>
-          <a:p>
-            <a:r>
-              <a:t>[/Sources]</a:t>
-            </a:r>
+            <a:endParaRPr dirty="0"/>
           </a:p>
         </p:txBody>
       </p:sp>
@@ -866,24 +801,7 @@
           <a:bodyPr/>
           <a:lstStyle/>
           <a:p>
-            <a:r>
-              <a:t>La pestaña Salidas muestra Producto: Cuaderno y Total: 102.5. El resultado coincide con 5 × 20.5.</a:t>
-            </a:r>
-          </a:p>
-          <a:p>
-            <a:r>
-              <a:t>[Sources]</a:t>
-            </a:r>
-          </a:p>
-          <a:p>
-            <a:r>
-              <a:t>- Evidencia de ejecución proporcionada por el estudiante: aecca6c3-bad4-4197-acc4-221969133efa.png</a:t>
-            </a:r>
-          </a:p>
-          <a:p>
-            <a:r>
-              <a:t>[/Sources]</a:t>
-            </a:r>
+            <a:endParaRPr dirty="0"/>
           </a:p>
         </p:txBody>
       </p:sp>
@@ -958,24 +876,7 @@
           <a:bodyPr/>
           <a:lstStyle/>
           <a:p>
-            <a:r>
-              <a:t>La tabla conserva edad y nombre con valores válidos. activo y division aparecen sin asignar porque sus instrucciones no superaron la comprobación semántica.</a:t>
-            </a:r>
-          </a:p>
-          <a:p>
-            <a:r>
-              <a:t>[Sources]</a:t>
-            </a:r>
-          </a:p>
-          <a:p>
-            <a:r>
-              <a:t>- Evidencia de ejecución proporcionada por el estudiante: aedfc2c5-e8fc-4c85-999b-1af328e282f3.png</a:t>
-            </a:r>
-          </a:p>
-          <a:p>
-            <a:r>
-              <a:t>[/Sources]</a:t>
-            </a:r>
+            <a:endParaRPr dirty="0"/>
           </a:p>
         </p:txBody>
       </p:sp>
@@ -1050,24 +951,7 @@
           <a:bodyPr/>
           <a:lstStyle/>
           <a:p>
-            <a:r>
-              <a:t>La pestaña Salidas muestra Sin salidas. El analizador detuvo las instrucciones que dependían de datos inválidos antes de presentar resultados.</a:t>
-            </a:r>
-          </a:p>
-          <a:p>
-            <a:r>
-              <a:t>[Sources]</a:t>
-            </a:r>
-          </a:p>
-          <a:p>
-            <a:r>
-              <a:t>- Evidencia de ejecución proporcionada por el estudiante: fba7561e-bc5b-4604-a906-ae11bbcf25cc.png</a:t>
-            </a:r>
-          </a:p>
-          <a:p>
-            <a:r>
-              <a:t>[/Sources]</a:t>
-            </a:r>
+            <a:endParaRPr dirty="0"/>
           </a:p>
         </p:txBody>
       </p:sp>
@@ -1142,24 +1026,7 @@
           <a:bodyPr/>
           <a:lstStyle/>
           <a:p>
-            <a:r>
-              <a:t>Se detectaron: edad duplicada, asignación String a int, promedio no declarado, int asignado a boolean, división entre cero y variableInexistente no declarada.</a:t>
-            </a:r>
-          </a:p>
-          <a:p>
-            <a:r>
-              <a:t>[Sources]</a:t>
-            </a:r>
-          </a:p>
-          <a:p>
-            <a:r>
-              <a:t>- Evidencia de ejecución proporcionada por el estudiante: eea19907-f38f-4fab-8bd6-f1c5b2cc8826.png</a:t>
-            </a:r>
-          </a:p>
-          <a:p>
-            <a:r>
-              <a:t>[/Sources]</a:t>
-            </a:r>
+            <a:endParaRPr dirty="0"/>
           </a:p>
         </p:txBody>
       </p:sp>
@@ -1234,19 +1101,7 @@
           <a:bodyPr/>
           <a:lstStyle/>
           <a:p>
-            <a:r>
-              <a:t>[Sources]</a:t>
-            </a:r>
-          </a:p>
-          <a:p>
-            <a:r>
-              <a:t>- Capturas de pantalla proporcionadas por el estudiante, 30 de agosto de 2026.</a:t>
-            </a:r>
-          </a:p>
-          <a:p>
-            <a:r>
-              <a:t>[/Sources]</a:t>
-            </a:r>
+            <a:endParaRPr dirty="0"/>
           </a:p>
         </p:txBody>
       </p:sp>
@@ -1321,29 +1176,7 @@
           <a:bodyPr/>
           <a:lstStyle/>
           <a:p>
-            <a:r>
-              <a:t>La actividad se presenta ahora desde una ventana JavaFX, pero mantiene el mismo motor de análisis semántico.</a:t>
-            </a:r>
-          </a:p>
-          <a:p>
-            <a:r>
-              <a:t>[Sources]</a:t>
-            </a:r>
-          </a:p>
-          <a:p>
-            <a:r>
-              <a:t>- https://openjfx.io/</a:t>
-            </a:r>
-          </a:p>
-          <a:p>
-            <a:r>
-              <a:t>- https://openjfx.io/javadoc/26/javafx.fxml/javafx/fxml/doc-files/introduction_to_fxml.html</a:t>
-            </a:r>
-          </a:p>
-          <a:p>
-            <a:r>
-              <a:t>[/Sources]</a:t>
-            </a:r>
+            <a:endParaRPr dirty="0"/>
           </a:p>
         </p:txBody>
       </p:sp>
@@ -1418,29 +1251,7 @@
           <a:bodyPr/>
           <a:lstStyle/>
           <a:p>
-            <a:r>
-              <a:t>Conclusión elaborada a partir de las cinco evidencias de ejecución de la práctica.</a:t>
-            </a:r>
-          </a:p>
-          <a:p>
-            <a:r>
-              <a:t>[Sources]</a:t>
-            </a:r>
-          </a:p>
-          <a:p>
-            <a:r>
-              <a:t>- https://openjfx.io/openjfx-docs/maven</a:t>
-            </a:r>
-          </a:p>
-          <a:p>
-            <a:r>
-              <a:t>- Evidencias de ejecución proporcionadas por el estudiante.</a:t>
-            </a:r>
-          </a:p>
-          <a:p>
-            <a:r>
-              <a:t>[/Sources]</a:t>
-            </a:r>
+            <a:endParaRPr dirty="0"/>
           </a:p>
         </p:txBody>
       </p:sp>
@@ -1515,44 +1326,7 @@
           <a:bodyPr/>
           <a:lstStyle/>
           <a:p>
-            <a:r>
-              <a:t>[Sources]</a:t>
-            </a:r>
-          </a:p>
-          <a:p>
-            <a:r>
-              <a:t>- https://openjfx.io/openjfx-docs/maven</a:t>
-            </a:r>
-          </a:p>
-          <a:p>
-            <a:r>
-              <a:t>- https://openjfx.io/javadoc/26/javafx.fxml/javafx/fxml/doc-files/introduction_to_fxml.html</a:t>
-            </a:r>
-          </a:p>
-          <a:p>
-            <a:r>
-              <a:t>- https://docs.oracle.com/javase/specs/jls/se17/html/jls-4.html</a:t>
-            </a:r>
-          </a:p>
-          <a:p>
-            <a:r>
-              <a:t>- https://docs.oracle.com/javase/specs/jls/se17/html/jls-5.html</a:t>
-            </a:r>
-          </a:p>
-          <a:p>
-            <a:r>
-              <a:t>- Aho, A. V., Lam, M. S., Sethi, R., &amp; Ullman, J. D. (2007). Compiladores: Principios, técnicas y herramientas (2.ª ed.). Pearson Educación.</a:t>
-            </a:r>
-          </a:p>
-          <a:p>
-            <a:r>
-              <a:t>- Tecnológico Nacional de México. (2026). Instrumentación didáctica de Lenguajes y Autómatas II [Documento institucional].</a:t>
-            </a:r>
-          </a:p>
-          <a:p>
-            <a:r>
-              <a:t>[/Sources]</a:t>
-            </a:r>
+            <a:endParaRPr dirty="0"/>
           </a:p>
         </p:txBody>
       </p:sp>
@@ -1627,19 +1401,7 @@
           <a:bodyPr/>
           <a:lstStyle/>
           <a:p>
-            <a:r>
-              <a:t>[Sources]</a:t>
-            </a:r>
-          </a:p>
-          <a:p>
-            <a:r>
-              <a:t>- Contenido y evidencias elaborados por el estudiante.</a:t>
-            </a:r>
-          </a:p>
-          <a:p>
-            <a:r>
-              <a:t>[/Sources]</a:t>
-            </a:r>
+            <a:endParaRPr dirty="0"/>
           </a:p>
         </p:txBody>
       </p:sp>
@@ -1714,24 +1476,7 @@
           <a:bodyPr/>
           <a:lstStyle/>
           <a:p>
-            <a:r>
-              <a:t>La decisión fue adaptar el proyecto existente, no reemplazarlo: JavaFX se usa como capa de presentación.</a:t>
-            </a:r>
-          </a:p>
-          <a:p>
-            <a:r>
-              <a:t>[Sources]</a:t>
-            </a:r>
-          </a:p>
-          <a:p>
-            <a:r>
-              <a:t>- https://openjfx.io/javadoc/26/javafx.fxml/javafx/fxml/doc-files/introduction_to_fxml.html</a:t>
-            </a:r>
-          </a:p>
-          <a:p>
-            <a:r>
-              <a:t>[/Sources]</a:t>
-            </a:r>
+            <a:endParaRPr dirty="0"/>
           </a:p>
         </p:txBody>
       </p:sp>
@@ -1806,19 +1551,7 @@
           <a:bodyPr/>
           <a:lstStyle/>
           <a:p>
-            <a:r>
-              <a:t>[Sources]</a:t>
-            </a:r>
-          </a:p>
-          <a:p>
-            <a:r>
-              <a:t>- Contenido y evidencias elaborados por el estudiante.</a:t>
-            </a:r>
-          </a:p>
-          <a:p>
-            <a:r>
-              <a:t>[/Sources]</a:t>
-            </a:r>
+            <a:endParaRPr dirty="0"/>
           </a:p>
         </p:txBody>
       </p:sp>
@@ -1893,19 +1626,7 @@
           <a:bodyPr/>
           <a:lstStyle/>
           <a:p>
-            <a:r>
-              <a:t>[Sources]</a:t>
-            </a:r>
-          </a:p>
-          <a:p>
-            <a:r>
-              <a:t>- Contenido y evidencias elaborados por el estudiante.</a:t>
-            </a:r>
-          </a:p>
-          <a:p>
-            <a:r>
-              <a:t>[/Sources]</a:t>
-            </a:r>
+            <a:endParaRPr dirty="0"/>
           </a:p>
         </p:txBody>
       </p:sp>
@@ -1980,39 +1701,7 @@
           <a:bodyPr/>
           <a:lstStyle/>
           <a:p>
-            <a:r>
-              <a:t>La tabla de símbolos y la comprobación de tipos forman parte del análisis semántico. FXML permite describir la jerarquía visual de JavaFX mediante XML.</a:t>
-            </a:r>
-          </a:p>
-          <a:p>
-            <a:r>
-              <a:t>[Sources]</a:t>
-            </a:r>
-          </a:p>
-          <a:p>
-            <a:r>
-              <a:t>- Aho, A. V., Lam, M. S., Sethi, R., &amp; Ullman, J. D. (2007). Compiladores: Principios, técnicas y herramientas (2.ª ed.). Pearson Educación.</a:t>
-            </a:r>
-          </a:p>
-          <a:p>
-            <a:r>
-              <a:t>- https://docs.oracle.com/javase/specs/jls/se17/html/jls-4.html</a:t>
-            </a:r>
-          </a:p>
-          <a:p>
-            <a:r>
-              <a:t>- https://docs.oracle.com/javase/specs/jls/se17/html/jls-5.html</a:t>
-            </a:r>
-          </a:p>
-          <a:p>
-            <a:r>
-              <a:t>- https://openjfx.io/javadoc/26/javafx.fxml/javafx/fxml/doc-files/introduction_to_fxml.html</a:t>
-            </a:r>
-          </a:p>
-          <a:p>
-            <a:r>
-              <a:t>[/Sources]</a:t>
-            </a:r>
+            <a:endParaRPr dirty="0"/>
           </a:p>
         </p:txBody>
       </p:sp>
@@ -2087,29 +1776,7 @@
           <a:bodyPr/>
           <a:lstStyle/>
           <a:p>
-            <a:r>
-              <a:t>Se utilizó la ruta de mvn.cmd incluida en la extensión Oracle porque el comando mvn no estaba registrado en el PATH de Windows. clean elimina la compilación anterior y javafx:run carga los módulos declarados en Maven antes de iniciar la ventana.</a:t>
-            </a:r>
-          </a:p>
-          <a:p>
-            <a:r>
-              <a:t>[Sources]</a:t>
-            </a:r>
-          </a:p>
-          <a:p>
-            <a:r>
-              <a:t>- https://openjfx.io/openjfx-docs/maven</a:t>
-            </a:r>
-          </a:p>
-          <a:p>
-            <a:r>
-              <a:t>- https://openjfx.io/openjfx-docs/ide-vscode.html</a:t>
-            </a:r>
-          </a:p>
-          <a:p>
-            <a:r>
-              <a:t>[/Sources]</a:t>
-            </a:r>
+            <a:endParaRPr dirty="0"/>
           </a:p>
         </p:txBody>
       </p:sp>
@@ -2184,19 +1851,7 @@
           <a:bodyPr/>
           <a:lstStyle/>
           <a:p>
-            <a:r>
-              <a:t>[Sources]</a:t>
-            </a:r>
-          </a:p>
-          <a:p>
-            <a:r>
-              <a:t>- Contenido y evidencias elaborados por el estudiante.</a:t>
-            </a:r>
-          </a:p>
-          <a:p>
-            <a:r>
-              <a:t>[/Sources]</a:t>
-            </a:r>
+            <a:endParaRPr dirty="0"/>
           </a:p>
         </p:txBody>
       </p:sp>
@@ -2271,19 +1926,7 @@
           <a:bodyPr/>
           <a:lstStyle/>
           <a:p>
-            <a:r>
-              <a:t>[Sources]</a:t>
-            </a:r>
-          </a:p>
-          <a:p>
-            <a:r>
-              <a:t>- https://www.cs.cornell.edu/courses/cs4120/2023sp/notes.html?id=semantic</a:t>
-            </a:r>
-          </a:p>
-          <a:p>
-            <a:r>
-              <a:t>[/Sources]</a:t>
-            </a:r>
+            <a:endParaRPr dirty="0"/>
           </a:p>
         </p:txBody>
       </p:sp>
@@ -11235,57 +10878,6 @@
       </p:sp>
       <p:sp>
         <p:nvSpPr>
-          <p:cNvPr id="4" name="Rectángulo 3">
-            <a:extLst>
-              <a:ext uri="{FF2B5EF4-FFF2-40B4-BE49-F238E27FC236}">
-                <a16:creationId xmlns:a16="http://schemas.microsoft.com/office/drawing/2014/main" id="{168C3E3B-41C7-4015-B44F-217E5F184FF6}"/>
-              </a:ext>
-            </a:extLst>
-          </p:cNvPr>
-          <p:cNvSpPr>
-            <a:spLocks noGrp="1"/>
-          </p:cNvSpPr>
-          <p:nvPr/>
-        </p:nvSpPr>
-        <p:spPr>
-          <a:xfrm>
-            <a:off x="781050" y="5286375"/>
-            <a:ext cx="8096250" cy="419100"/>
-          </a:xfrm>
-          <a:prstGeom prst="rect">
-            <a:avLst/>
-          </a:prstGeom>
-          <a:noFill/>
-          <a:ln w="0">
-            <a:noFill/>
-            <a:prstDash val="solid"/>
-          </a:ln>
-        </p:spPr>
-        <p:txBody>
-          <a:bodyPr/>
-          <a:lstStyle/>
-          <a:p>
-            <a:pPr algn="l">
-              <a:buNone/>
-              <a:defRPr sz="1725" b="1">
-                <a:solidFill>
-                  <a:srgbClr val="FFFFFF"/>
-                </a:solidFill>
-              </a:defRPr>
-            </a:pPr>
-            <a:r>
-              <a:rPr sz="1725" b="1">
-                <a:solidFill>
-                  <a:srgbClr val="FFFFFF"/>
-                </a:solidFill>
-              </a:rPr>
-              <a:t>La evidencia obtenida confirma el objetivo de la actividad 1.2.</a:t>
-            </a:r>
-          </a:p>
-        </p:txBody>
-      </p:sp>
-      <p:sp>
-        <p:nvSpPr>
           <p:cNvPr id="5" name="Rectángulo 4">
             <a:extLst>
               <a:ext uri="{FF2B5EF4-FFF2-40B4-BE49-F238E27FC236}">
@@ -12378,15 +11970,15 @@
               </a:defRPr>
             </a:pPr>
             <a:r>
-              <a:rPr sz="1400" b="1">
+              <a:rPr lang="es-MX" sz="1200" b="1" dirty="0">
                 <a:solidFill>
                   <a:srgbClr val="17201D"/>
                 </a:solidFill>
                 <a:hlinkClick r:id="rId3"/>
               </a:rPr>
-              <a:t>PEGAR AQUÍ EL ENLACE DEL REPOSITORIO</a:t>
-            </a:r>
-            <a:endParaRPr sz="1400" b="1">
+              <a:t>https://github.com/amaurycolochos-cpu/LENGUAJES-Y-AUTOMATAS-II/tree/main/LYA-II-Tema-1/AnalizadorSemantico-Unidad-1-JavaFX</a:t>
+            </a:r>
+            <a:endParaRPr lang="es-MX" sz="1200" b="1" dirty="0">
               <a:solidFill>
                 <a:srgbClr val="17201D"/>
               </a:solidFill>
@@ -12401,7 +11993,22 @@
                 </a:solidFill>
               </a:defRPr>
             </a:pPr>
-            <a:endParaRPr sz="1400" b="1">
+            <a:endParaRPr lang="es-MX" sz="1200" b="1" dirty="0">
+              <a:solidFill>
+                <a:srgbClr val="17201D"/>
+              </a:solidFill>
+            </a:endParaRPr>
+          </a:p>
+          <a:p>
+            <a:pPr algn="l">
+              <a:buNone/>
+              <a:defRPr sz="1725" b="1">
+                <a:solidFill>
+                  <a:srgbClr val="17201D"/>
+                </a:solidFill>
+              </a:defRPr>
+            </a:pPr>
+            <a:endParaRPr sz="1200" b="1" dirty="0">
               <a:solidFill>
                 <a:srgbClr val="17201D"/>
               </a:solidFill>

</xml_diff>